<commit_message>
auto sync: 2026-08-15 09:00
</commit_message>
<xml_diff>
--- a/journal/group_meeting/葛良晨 260813.pptx
+++ b/journal/group_meeting/葛良晨 260813.pptx
@@ -8,7 +8,7 @@
     <p:notesMasterId r:id="rId6"/>
   </p:notesMasterIdLst>
   <p:handoutMasterIdLst>
-    <p:handoutMasterId r:id="rId16"/>
+    <p:handoutMasterId r:id="rId17"/>
   </p:handoutMasterIdLst>
   <p:sldIdLst>
     <p:sldId id="257" r:id="rId3"/>
@@ -23,6 +23,7 @@
     <p:sldId id="263" r:id="rId13"/>
     <p:sldId id="261" r:id="rId14"/>
     <p:sldId id="264" r:id="rId15"/>
+    <p:sldId id="269" r:id="rId16"/>
   </p:sldIdLst>
   <p:sldSz cx="12192000" cy="6858000"/>
   <p:notesSz cx="6858000" cy="9144000"/>
@@ -4187,6 +4188,156 @@
     </p:spTree>
     <p:custDataLst>
       <p:tags r:id="rId2"/>
+    </p:custDataLst>
+  </p:cSld>
+  <p:clrMapOvr>
+    <a:masterClrMapping/>
+  </p:clrMapOvr>
+</p:sld>
+</file>
+
+<file path=ppt/slides/slide13.xml><?xml version="1.0" encoding="utf-8"?>
+<p:sld xmlns:a="http://schemas.openxmlformats.org/drawingml/2006/main" xmlns:r="http://schemas.openxmlformats.org/officeDocument/2006/relationships" xmlns:p="http://schemas.openxmlformats.org/presentationml/2006/main">
+  <p:cSld>
+    <p:spTree>
+      <p:nvGrpSpPr>
+        <p:cNvPr id="1" name=""/>
+        <p:cNvGrpSpPr/>
+        <p:nvPr/>
+      </p:nvGrpSpPr>
+      <p:grpSpPr/>
+      <p:sp>
+        <p:nvSpPr>
+          <p:cNvPr id="4" name="圆角矩形 3"/>
+          <p:cNvSpPr/>
+          <p:nvPr/>
+        </p:nvSpPr>
+        <p:spPr>
+          <a:xfrm>
+            <a:off x="7875905" y="1426845"/>
+            <a:ext cx="825500" cy="3328035"/>
+          </a:xfrm>
+          <a:prstGeom prst="roundRect">
+            <a:avLst/>
+          </a:prstGeom>
+        </p:spPr>
+        <p:style>
+          <a:lnRef idx="2">
+            <a:schemeClr val="accent1">
+              <a:lumMod val="75000"/>
+            </a:schemeClr>
+          </a:lnRef>
+          <a:fillRef idx="1">
+            <a:schemeClr val="accent1"/>
+          </a:fillRef>
+          <a:effectRef idx="0">
+            <a:srgbClr val="FFFFFF"/>
+          </a:effectRef>
+          <a:fontRef idx="minor">
+            <a:schemeClr val="lt1"/>
+          </a:fontRef>
+        </p:style>
+        <p:txBody>
+          <a:bodyPr rtlCol="0" anchor="ctr"/>
+          <a:p>
+            <a:pPr algn="ctr"/>
+            <a:r>
+              <a:rPr lang="en-US" altLang="zh-CN"/>
+              <a:t>204</a:t>
+            </a:r>
+            <a:endParaRPr lang="en-US" altLang="zh-CN"/>
+          </a:p>
+        </p:txBody>
+      </p:sp>
+      <p:sp>
+        <p:nvSpPr>
+          <p:cNvPr id="6" name="圆角矩形 5"/>
+          <p:cNvSpPr/>
+          <p:nvPr/>
+        </p:nvSpPr>
+        <p:spPr>
+          <a:xfrm>
+            <a:off x="5407660" y="3971290"/>
+            <a:ext cx="1450340" cy="783590"/>
+          </a:xfrm>
+          <a:prstGeom prst="roundRect">
+            <a:avLst/>
+          </a:prstGeom>
+        </p:spPr>
+        <p:style>
+          <a:lnRef idx="2">
+            <a:schemeClr val="accent1">
+              <a:lumMod val="75000"/>
+            </a:schemeClr>
+          </a:lnRef>
+          <a:fillRef idx="1">
+            <a:schemeClr val="accent1"/>
+          </a:fillRef>
+          <a:effectRef idx="0">
+            <a:srgbClr val="FFFFFF"/>
+          </a:effectRef>
+          <a:fontRef idx="minor">
+            <a:schemeClr val="lt1"/>
+          </a:fontRef>
+        </p:style>
+        <p:txBody>
+          <a:bodyPr rtlCol="0" anchor="ctr"/>
+          <a:p>
+            <a:pPr algn="ctr"/>
+            <a:r>
+              <a:rPr lang="en-US" altLang="zh-CN"/>
+              <a:t>SPI</a:t>
+            </a:r>
+            <a:endParaRPr lang="en-US" altLang="zh-CN"/>
+          </a:p>
+        </p:txBody>
+      </p:sp>
+      <p:sp>
+        <p:nvSpPr>
+          <p:cNvPr id="7" name="圆角矩形 6"/>
+          <p:cNvSpPr/>
+          <p:nvPr/>
+        </p:nvSpPr>
+        <p:spPr>
+          <a:xfrm>
+            <a:off x="5407660" y="1284605"/>
+            <a:ext cx="1376680" cy="910590"/>
+          </a:xfrm>
+          <a:prstGeom prst="roundRect">
+            <a:avLst/>
+          </a:prstGeom>
+        </p:spPr>
+        <p:style>
+          <a:lnRef idx="2">
+            <a:schemeClr val="accent1">
+              <a:lumMod val="75000"/>
+            </a:schemeClr>
+          </a:lnRef>
+          <a:fillRef idx="1">
+            <a:schemeClr val="accent1"/>
+          </a:fillRef>
+          <a:effectRef idx="0">
+            <a:srgbClr val="FFFFFF"/>
+          </a:effectRef>
+          <a:fontRef idx="minor">
+            <a:schemeClr val="lt1"/>
+          </a:fontRef>
+        </p:style>
+        <p:txBody>
+          <a:bodyPr rtlCol="0" anchor="ctr"/>
+          <a:p>
+            <a:pPr algn="ctr"/>
+            <a:r>
+              <a:rPr lang="zh-CN" altLang="en-US"/>
+              <a:t>校准</a:t>
+            </a:r>
+            <a:endParaRPr lang="zh-CN" altLang="en-US"/>
+          </a:p>
+        </p:txBody>
+      </p:sp>
+    </p:spTree>
+    <p:custDataLst>
+      <p:tags r:id="rId1"/>
     </p:custDataLst>
   </p:cSld>
   <p:clrMapOvr>
@@ -13613,7 +13764,7 @@
         </p:blipFill>
         <p:spPr>
           <a:xfrm>
-            <a:off x="475615" y="3934460"/>
+            <a:off x="170815" y="2646045"/>
             <a:ext cx="3906520" cy="3906520"/>
           </a:xfrm>
           <a:prstGeom prst="rect">
@@ -14689,6 +14840,14 @@
 </p:tagLst>
 </file>
 
+<file path=ppt/tags/tag75.xml><?xml version="1.0" encoding="utf-8"?>
+<p:tagLst xmlns:p="http://schemas.openxmlformats.org/presentationml/2006/main">
+  <p:tag name="KSO_WM_BEAUTIFY_FLAG" val="#wm#"/>
+  <p:tag name="KSO_WM_TEMPLATE_CATEGORY" val="custom"/>
+  <p:tag name="KSO_WM_TEMPLATE_INDEX" val="20205081"/>
+</p:tagLst>
+</file>
+
 <file path=ppt/tags/tag8.xml><?xml version="1.0" encoding="utf-8"?>
 <p:tagLst xmlns:p="http://schemas.openxmlformats.org/presentationml/2006/main">
   <p:tag name="KSO_WM_UNIT_HIGHLIGHT" val="0"/>

</xml_diff>